<commit_message>
QTY vs Value slides: 100% stacked charts
Co-Authored-By: Claude Opus 5.5 <noreply@anthropic.com>
Claude-Session: https://claude.ai/code/session_01Cx9kswyecF7JAB1Rr5vVcV
</commit_message>
<xml_diff>
--- a/nedp_deck/QTY_vs_Value_2slides.pptx
+++ b/nedp_deck/QTY_vs_Value_2slides.pptx
@@ -112,11 +112,11 @@
 <c:chartSpace xmlns:c="http://schemas.openxmlformats.org/drawingml/2006/chart" xmlns:a="http://schemas.openxmlformats.org/drawingml/2006/main" xmlns:r="http://schemas.openxmlformats.org/officeDocument/2006/relationships">
   <c:date1904 val="0"/>
   <c:chart>
-    <c:autoTitleDeleted val="1"/>
+    <c:autoTitleDeleted val="0"/>
     <c:plotArea>
       <c:barChart>
         <c:barDir val="col"/>
-        <c:grouping val="clustered"/>
+        <c:grouping val="percentStacked"/>
         <c:ser>
           <c:idx val="0"/>
           <c:order val="0"/>
@@ -126,43 +126,21 @@
               <c:strCache>
                 <c:ptCount val="1"/>
                 <c:pt idx="0">
-                  <c:v>Txn</c:v>
+                  <c:v>Light</c:v>
                 </c:pt>
               </c:strCache>
             </c:strRef>
           </c:tx>
-          <c:dPt>
-            <c:idx val="0"/>
-            <c:spPr>
+          <c:spPr>
+            <a:solidFill>
+              <a:srgbClr val="D9D9D9"/>
+            </a:solidFill>
+            <a:ln>
               <a:solidFill>
-                <a:srgbClr val="D9D9D9"/>
+                <a:srgbClr val="FFFFFF"/>
               </a:solidFill>
-            </c:spPr>
-          </c:dPt>
-          <c:dPt>
-            <c:idx val="1"/>
-            <c:spPr>
-              <a:solidFill>
-                <a:srgbClr val="A6A6A6"/>
-              </a:solidFill>
-            </c:spPr>
-          </c:dPt>
-          <c:dPt>
-            <c:idx val="2"/>
-            <c:spPr>
-              <a:solidFill>
-                <a:srgbClr val="595959"/>
-              </a:solidFill>
-            </c:spPr>
-          </c:dPt>
-          <c:dPt>
-            <c:idx val="3"/>
-            <c:spPr>
-              <a:solidFill>
-                <a:srgbClr val="000000"/>
-              </a:solidFill>
-            </c:spPr>
-          </c:dPt>
+            </a:ln>
+          </c:spPr>
           <c:dLbls>
             <c:dLbl>
               <c:idx val="0"/>
@@ -172,26 +150,17 @@
                   <a:lstStyle/>
                   <a:p>
                     <a:r>
-                      <a:rPr sz="1500" b="1">
-                        <a:latin typeface="Neue Haas Grotesk Text Pro"/>
-                      </a:rPr>
-                      <a:t>248</a:t>
-                    </a:r>
-                  </a:p>
-                  <a:p>
-                    <a:r>
-                      <a:rPr sz="1200">
+                      <a:rPr sz="1100" b="1">
                         <a:solidFill>
-                          <a:srgbClr val="6B6B6B"/>
+                          <a:srgbClr val="000000"/>
                         </a:solidFill>
                         <a:latin typeface="Neue Haas Grotesk Text Pro"/>
                       </a:rPr>
-                      <a:t>32% share</a:t>
+                      <a:t>109 (41%)</a:t>
                     </a:r>
                   </a:p>
                 </c:rich>
               </c:tx>
-              <c:dLblPos val="outEnd"/>
               <c:showLegendKey val="0"/>
               <c:showVal val="1"/>
               <c:showCatName val="0"/>
@@ -207,26 +176,17 @@
                   <a:lstStyle/>
                   <a:p>
                     <a:r>
-                      <a:rPr sz="1500" b="1">
-                        <a:latin typeface="Neue Haas Grotesk Text Pro"/>
-                      </a:rPr>
-                      <a:t>223</a:t>
-                    </a:r>
-                  </a:p>
-                  <a:p>
-                    <a:r>
-                      <a:rPr sz="1200">
+                      <a:rPr sz="1100" b="1">
                         <a:solidFill>
-                          <a:srgbClr val="6B6B6B"/>
+                          <a:srgbClr val="000000"/>
                         </a:solidFill>
                         <a:latin typeface="Neue Haas Grotesk Text Pro"/>
                       </a:rPr>
-                      <a:t>29% share</a:t>
+                      <a:t>52 (27%)</a:t>
                     </a:r>
                   </a:p>
                 </c:rich>
               </c:tx>
-              <c:dLblPos val="outEnd"/>
               <c:showLegendKey val="0"/>
               <c:showVal val="1"/>
               <c:showCatName val="0"/>
@@ -242,26 +202,17 @@
                   <a:lstStyle/>
                   <a:p>
                     <a:r>
-                      <a:rPr sz="1500" b="1">
-                        <a:latin typeface="Neue Haas Grotesk Text Pro"/>
-                      </a:rPr>
-                      <a:t>218</a:t>
-                    </a:r>
-                  </a:p>
-                  <a:p>
-                    <a:r>
-                      <a:rPr sz="1200">
+                      <a:rPr sz="1100" b="1">
                         <a:solidFill>
-                          <a:srgbClr val="6B6B6B"/>
+                          <a:srgbClr val="000000"/>
                         </a:solidFill>
                         <a:latin typeface="Neue Haas Grotesk Text Pro"/>
                       </a:rPr>
-                      <a:t>29% share</a:t>
+                      <a:t>53 (23%)</a:t>
                     </a:r>
                   </a:p>
                 </c:rich>
               </c:tx>
-              <c:dLblPos val="outEnd"/>
               <c:showLegendKey val="0"/>
               <c:showVal val="1"/>
               <c:showCatName val="0"/>
@@ -277,26 +228,43 @@
                   <a:lstStyle/>
                   <a:p>
                     <a:r>
-                      <a:rPr sz="1500" b="1">
-                        <a:latin typeface="Neue Haas Grotesk Text Pro"/>
-                      </a:rPr>
-                      <a:t>75</a:t>
-                    </a:r>
-                  </a:p>
-                  <a:p>
-                    <a:r>
-                      <a:rPr sz="1200">
+                      <a:rPr sz="1100" b="1">
                         <a:solidFill>
-                          <a:srgbClr val="6B6B6B"/>
+                          <a:srgbClr val="000000"/>
                         </a:solidFill>
                         <a:latin typeface="Neue Haas Grotesk Text Pro"/>
                       </a:rPr>
-                      <a:t>10% share</a:t>
+                      <a:t>34 (43%)</a:t>
                     </a:r>
                   </a:p>
                 </c:rich>
               </c:tx>
-              <c:dLblPos val="outEnd"/>
+              <c:showLegendKey val="0"/>
+              <c:showVal val="1"/>
+              <c:showCatName val="0"/>
+              <c:showSerName val="0"/>
+              <c:showPercent val="0"/>
+              <c:showBubbleSize val="0"/>
+            </c:dLbl>
+            <c:dLbl>
+              <c:idx val="4"/>
+              <c:tx>
+                <c:rich>
+                  <a:bodyPr/>
+                  <a:lstStyle/>
+                  <a:p>
+                    <a:r>
+                      <a:rPr sz="1100" b="1">
+                        <a:solidFill>
+                          <a:srgbClr val="000000"/>
+                        </a:solidFill>
+                        <a:latin typeface="Neue Haas Grotesk Text Pro"/>
+                      </a:rPr>
+                      <a:t>248 (32%)</a:t>
+                    </a:r>
+                  </a:p>
+                </c:rich>
+              </c:tx>
               <c:showLegendKey val="0"/>
               <c:showVal val="1"/>
               <c:showCatName val="0"/>
@@ -314,47 +282,687 @@
           </c:dLbls>
           <c:cat>
             <c:strRef>
-              <c:f>Sheet1!$A$2:$A$5</c:f>
+              <c:f>Sheet1!$A$2:$A$6</c:f>
               <c:strCache>
-                <c:ptCount val="4"/>
+                <c:ptCount val="5"/>
                 <c:pt idx="0">
-                  <c:v>Light</c:v>
+                  <c:v>2023</c:v>
                 </c:pt>
                 <c:pt idx="1">
-                  <c:v>Small</c:v>
+                  <c:v>2024</c:v>
                 </c:pt>
                 <c:pt idx="2">
-                  <c:v>Medium</c:v>
+                  <c:v>2025</c:v>
                 </c:pt>
                 <c:pt idx="3">
-                  <c:v>Heavy</c:v>
+                  <c:v>2026*</c:v>
+                </c:pt>
+                <c:pt idx="4">
+                  <c:v>Total</c:v>
                 </c:pt>
               </c:strCache>
             </c:strRef>
           </c:cat>
           <c:val>
             <c:numRef>
-              <c:f>Sheet1!$B$2:$B$5</c:f>
+              <c:f>Sheet1!$B$2:$B$6</c:f>
               <c:numCache>
                 <c:formatCode>General</c:formatCode>
-                <c:ptCount val="4"/>
+                <c:ptCount val="5"/>
                 <c:pt idx="0">
+                  <c:v>109</c:v>
+                </c:pt>
+                <c:pt idx="1">
+                  <c:v>52</c:v>
+                </c:pt>
+                <c:pt idx="2">
+                  <c:v>53</c:v>
+                </c:pt>
+                <c:pt idx="3">
+                  <c:v>34</c:v>
+                </c:pt>
+                <c:pt idx="4">
                   <c:v>248</c:v>
                 </c:pt>
+              </c:numCache>
+            </c:numRef>
+          </c:val>
+        </c:ser>
+        <c:ser>
+          <c:idx val="1"/>
+          <c:order val="1"/>
+          <c:tx>
+            <c:strRef>
+              <c:f>Sheet1!$C$1</c:f>
+              <c:strCache>
+                <c:ptCount val="1"/>
+                <c:pt idx="0">
+                  <c:v>Small</c:v>
+                </c:pt>
+              </c:strCache>
+            </c:strRef>
+          </c:tx>
+          <c:spPr>
+            <a:solidFill>
+              <a:srgbClr val="A6A6A6"/>
+            </a:solidFill>
+            <a:ln>
+              <a:solidFill>
+                <a:srgbClr val="FFFFFF"/>
+              </a:solidFill>
+            </a:ln>
+          </c:spPr>
+          <c:dLbls>
+            <c:dLbl>
+              <c:idx val="0"/>
+              <c:tx>
+                <c:rich>
+                  <a:bodyPr/>
+                  <a:lstStyle/>
+                  <a:p>
+                    <a:r>
+                      <a:rPr sz="1100" b="1">
+                        <a:solidFill>
+                          <a:srgbClr val="000000"/>
+                        </a:solidFill>
+                        <a:latin typeface="Neue Haas Grotesk Text Pro"/>
+                      </a:rPr>
+                      <a:t>68 (25%)</a:t>
+                    </a:r>
+                  </a:p>
+                </c:rich>
+              </c:tx>
+              <c:showLegendKey val="0"/>
+              <c:showVal val="1"/>
+              <c:showCatName val="0"/>
+              <c:showSerName val="0"/>
+              <c:showPercent val="0"/>
+              <c:showBubbleSize val="0"/>
+            </c:dLbl>
+            <c:dLbl>
+              <c:idx val="1"/>
+              <c:tx>
+                <c:rich>
+                  <a:bodyPr/>
+                  <a:lstStyle/>
+                  <a:p>
+                    <a:r>
+                      <a:rPr sz="1100" b="1">
+                        <a:solidFill>
+                          <a:srgbClr val="000000"/>
+                        </a:solidFill>
+                        <a:latin typeface="Neue Haas Grotesk Text Pro"/>
+                      </a:rPr>
+                      <a:t>52 (27%)</a:t>
+                    </a:r>
+                  </a:p>
+                </c:rich>
+              </c:tx>
+              <c:showLegendKey val="0"/>
+              <c:showVal val="1"/>
+              <c:showCatName val="0"/>
+              <c:showSerName val="0"/>
+              <c:showPercent val="0"/>
+              <c:showBubbleSize val="0"/>
+            </c:dLbl>
+            <c:dLbl>
+              <c:idx val="2"/>
+              <c:tx>
+                <c:rich>
+                  <a:bodyPr/>
+                  <a:lstStyle/>
+                  <a:p>
+                    <a:r>
+                      <a:rPr sz="1100" b="1">
+                        <a:solidFill>
+                          <a:srgbClr val="000000"/>
+                        </a:solidFill>
+                        <a:latin typeface="Neue Haas Grotesk Text Pro"/>
+                      </a:rPr>
+                      <a:t>75 (33%)</a:t>
+                    </a:r>
+                  </a:p>
+                </c:rich>
+              </c:tx>
+              <c:showLegendKey val="0"/>
+              <c:showVal val="1"/>
+              <c:showCatName val="0"/>
+              <c:showSerName val="0"/>
+              <c:showPercent val="0"/>
+              <c:showBubbleSize val="0"/>
+            </c:dLbl>
+            <c:dLbl>
+              <c:idx val="3"/>
+              <c:tx>
+                <c:rich>
+                  <a:bodyPr/>
+                  <a:lstStyle/>
+                  <a:p>
+                    <a:r>
+                      <a:rPr sz="1100" b="1">
+                        <a:solidFill>
+                          <a:srgbClr val="000000"/>
+                        </a:solidFill>
+                        <a:latin typeface="Neue Haas Grotesk Text Pro"/>
+                      </a:rPr>
+                      <a:t>28 (35%)</a:t>
+                    </a:r>
+                  </a:p>
+                </c:rich>
+              </c:tx>
+              <c:showLegendKey val="0"/>
+              <c:showVal val="1"/>
+              <c:showCatName val="0"/>
+              <c:showSerName val="0"/>
+              <c:showPercent val="0"/>
+              <c:showBubbleSize val="0"/>
+            </c:dLbl>
+            <c:dLbl>
+              <c:idx val="4"/>
+              <c:tx>
+                <c:rich>
+                  <a:bodyPr/>
+                  <a:lstStyle/>
+                  <a:p>
+                    <a:r>
+                      <a:rPr sz="1100" b="1">
+                        <a:solidFill>
+                          <a:srgbClr val="000000"/>
+                        </a:solidFill>
+                        <a:latin typeface="Neue Haas Grotesk Text Pro"/>
+                      </a:rPr>
+                      <a:t>223 (29%)</a:t>
+                    </a:r>
+                  </a:p>
+                </c:rich>
+              </c:tx>
+              <c:showLegendKey val="0"/>
+              <c:showVal val="1"/>
+              <c:showCatName val="0"/>
+              <c:showSerName val="0"/>
+              <c:showPercent val="0"/>
+              <c:showBubbleSize val="0"/>
+            </c:dLbl>
+            <c:showLegendKey val="0"/>
+            <c:showVal val="0"/>
+            <c:showCatName val="0"/>
+            <c:showSerName val="0"/>
+            <c:showPercent val="0"/>
+            <c:showBubbleSize val="0"/>
+            <c:showLeaderLines val="1"/>
+          </c:dLbls>
+          <c:cat>
+            <c:strRef>
+              <c:f>Sheet1!$A$2:$A$6</c:f>
+              <c:strCache>
+                <c:ptCount val="5"/>
+                <c:pt idx="0">
+                  <c:v>2023</c:v>
+                </c:pt>
                 <c:pt idx="1">
+                  <c:v>2024</c:v>
+                </c:pt>
+                <c:pt idx="2">
+                  <c:v>2025</c:v>
+                </c:pt>
+                <c:pt idx="3">
+                  <c:v>2026*</c:v>
+                </c:pt>
+                <c:pt idx="4">
+                  <c:v>Total</c:v>
+                </c:pt>
+              </c:strCache>
+            </c:strRef>
+          </c:cat>
+          <c:val>
+            <c:numRef>
+              <c:f>Sheet1!$C$2:$C$6</c:f>
+              <c:numCache>
+                <c:formatCode>General</c:formatCode>
+                <c:ptCount val="5"/>
+                <c:pt idx="0">
+                  <c:v>68</c:v>
+                </c:pt>
+                <c:pt idx="1">
+                  <c:v>52</c:v>
+                </c:pt>
+                <c:pt idx="2">
+                  <c:v>75</c:v>
+                </c:pt>
+                <c:pt idx="3">
+                  <c:v>28</c:v>
+                </c:pt>
+                <c:pt idx="4">
                   <c:v>223</c:v>
                 </c:pt>
+              </c:numCache>
+            </c:numRef>
+          </c:val>
+        </c:ser>
+        <c:ser>
+          <c:idx val="2"/>
+          <c:order val="2"/>
+          <c:tx>
+            <c:strRef>
+              <c:f>Sheet1!$D$1</c:f>
+              <c:strCache>
+                <c:ptCount val="1"/>
+                <c:pt idx="0">
+                  <c:v>Medium</c:v>
+                </c:pt>
+              </c:strCache>
+            </c:strRef>
+          </c:tx>
+          <c:spPr>
+            <a:solidFill>
+              <a:srgbClr val="595959"/>
+            </a:solidFill>
+            <a:ln>
+              <a:solidFill>
+                <a:srgbClr val="FFFFFF"/>
+              </a:solidFill>
+            </a:ln>
+          </c:spPr>
+          <c:dLbls>
+            <c:dLbl>
+              <c:idx val="0"/>
+              <c:tx>
+                <c:rich>
+                  <a:bodyPr/>
+                  <a:lstStyle/>
+                  <a:p>
+                    <a:r>
+                      <a:rPr sz="1100" b="1">
+                        <a:solidFill>
+                          <a:srgbClr val="FFFFFF"/>
+                        </a:solidFill>
+                        <a:latin typeface="Neue Haas Grotesk Text Pro"/>
+                      </a:rPr>
+                      <a:t>74 (28%)</a:t>
+                    </a:r>
+                  </a:p>
+                </c:rich>
+              </c:tx>
+              <c:showLegendKey val="0"/>
+              <c:showVal val="1"/>
+              <c:showCatName val="0"/>
+              <c:showSerName val="0"/>
+              <c:showPercent val="0"/>
+              <c:showBubbleSize val="0"/>
+            </c:dLbl>
+            <c:dLbl>
+              <c:idx val="1"/>
+              <c:tx>
+                <c:rich>
+                  <a:bodyPr/>
+                  <a:lstStyle/>
+                  <a:p>
+                    <a:r>
+                      <a:rPr sz="1100" b="1">
+                        <a:solidFill>
+                          <a:srgbClr val="FFFFFF"/>
+                        </a:solidFill>
+                        <a:latin typeface="Neue Haas Grotesk Text Pro"/>
+                      </a:rPr>
+                      <a:t>70 (37%)</a:t>
+                    </a:r>
+                  </a:p>
+                </c:rich>
+              </c:tx>
+              <c:showLegendKey val="0"/>
+              <c:showVal val="1"/>
+              <c:showCatName val="0"/>
+              <c:showSerName val="0"/>
+              <c:showPercent val="0"/>
+              <c:showBubbleSize val="0"/>
+            </c:dLbl>
+            <c:dLbl>
+              <c:idx val="2"/>
+              <c:tx>
+                <c:rich>
+                  <a:bodyPr/>
+                  <a:lstStyle/>
+                  <a:p>
+                    <a:r>
+                      <a:rPr sz="1100" b="1">
+                        <a:solidFill>
+                          <a:srgbClr val="FFFFFF"/>
+                        </a:solidFill>
+                        <a:latin typeface="Neue Haas Grotesk Text Pro"/>
+                      </a:rPr>
+                      <a:t>60 (26%)</a:t>
+                    </a:r>
+                  </a:p>
+                </c:rich>
+              </c:tx>
+              <c:showLegendKey val="0"/>
+              <c:showVal val="1"/>
+              <c:showCatName val="0"/>
+              <c:showSerName val="0"/>
+              <c:showPercent val="0"/>
+              <c:showBubbleSize val="0"/>
+            </c:dLbl>
+            <c:dLbl>
+              <c:idx val="3"/>
+              <c:tx>
+                <c:rich>
+                  <a:bodyPr/>
+                  <a:lstStyle/>
+                  <a:p>
+                    <a:r>
+                      <a:rPr sz="1100" b="1">
+                        <a:solidFill>
+                          <a:srgbClr val="FFFFFF"/>
+                        </a:solidFill>
+                        <a:latin typeface="Neue Haas Grotesk Text Pro"/>
+                      </a:rPr>
+                      <a:t>14 (18%)</a:t>
+                    </a:r>
+                  </a:p>
+                </c:rich>
+              </c:tx>
+              <c:showLegendKey val="0"/>
+              <c:showVal val="1"/>
+              <c:showCatName val="0"/>
+              <c:showSerName val="0"/>
+              <c:showPercent val="0"/>
+              <c:showBubbleSize val="0"/>
+            </c:dLbl>
+            <c:dLbl>
+              <c:idx val="4"/>
+              <c:tx>
+                <c:rich>
+                  <a:bodyPr/>
+                  <a:lstStyle/>
+                  <a:p>
+                    <a:r>
+                      <a:rPr sz="1100" b="1">
+                        <a:solidFill>
+                          <a:srgbClr val="FFFFFF"/>
+                        </a:solidFill>
+                        <a:latin typeface="Neue Haas Grotesk Text Pro"/>
+                      </a:rPr>
+                      <a:t>218 (29%)</a:t>
+                    </a:r>
+                  </a:p>
+                </c:rich>
+              </c:tx>
+              <c:showLegendKey val="0"/>
+              <c:showVal val="1"/>
+              <c:showCatName val="0"/>
+              <c:showSerName val="0"/>
+              <c:showPercent val="0"/>
+              <c:showBubbleSize val="0"/>
+            </c:dLbl>
+            <c:showLegendKey val="0"/>
+            <c:showVal val="0"/>
+            <c:showCatName val="0"/>
+            <c:showSerName val="0"/>
+            <c:showPercent val="0"/>
+            <c:showBubbleSize val="0"/>
+            <c:showLeaderLines val="1"/>
+          </c:dLbls>
+          <c:cat>
+            <c:strRef>
+              <c:f>Sheet1!$A$2:$A$6</c:f>
+              <c:strCache>
+                <c:ptCount val="5"/>
+                <c:pt idx="0">
+                  <c:v>2023</c:v>
+                </c:pt>
+                <c:pt idx="1">
+                  <c:v>2024</c:v>
+                </c:pt>
                 <c:pt idx="2">
+                  <c:v>2025</c:v>
+                </c:pt>
+                <c:pt idx="3">
+                  <c:v>2026*</c:v>
+                </c:pt>
+                <c:pt idx="4">
+                  <c:v>Total</c:v>
+                </c:pt>
+              </c:strCache>
+            </c:strRef>
+          </c:cat>
+          <c:val>
+            <c:numRef>
+              <c:f>Sheet1!$D$2:$D$6</c:f>
+              <c:numCache>
+                <c:formatCode>General</c:formatCode>
+                <c:ptCount val="5"/>
+                <c:pt idx="0">
+                  <c:v>74</c:v>
+                </c:pt>
+                <c:pt idx="1">
+                  <c:v>70</c:v>
+                </c:pt>
+                <c:pt idx="2">
+                  <c:v>60</c:v>
+                </c:pt>
+                <c:pt idx="3">
+                  <c:v>14</c:v>
+                </c:pt>
+                <c:pt idx="4">
                   <c:v>218</c:v>
                 </c:pt>
+              </c:numCache>
+            </c:numRef>
+          </c:val>
+        </c:ser>
+        <c:ser>
+          <c:idx val="3"/>
+          <c:order val="3"/>
+          <c:tx>
+            <c:strRef>
+              <c:f>Sheet1!$E$1</c:f>
+              <c:strCache>
+                <c:ptCount val="1"/>
+                <c:pt idx="0">
+                  <c:v>Heavy</c:v>
+                </c:pt>
+              </c:strCache>
+            </c:strRef>
+          </c:tx>
+          <c:spPr>
+            <a:solidFill>
+              <a:srgbClr val="000000"/>
+            </a:solidFill>
+            <a:ln>
+              <a:solidFill>
+                <a:srgbClr val="FFFFFF"/>
+              </a:solidFill>
+            </a:ln>
+          </c:spPr>
+          <c:dLbls>
+            <c:dLbl>
+              <c:idx val="0"/>
+              <c:tx>
+                <c:rich>
+                  <a:bodyPr/>
+                  <a:lstStyle/>
+                  <a:p>
+                    <a:r>
+                      <a:rPr sz="1100" b="1">
+                        <a:solidFill>
+                          <a:srgbClr val="FFFFFF"/>
+                        </a:solidFill>
+                        <a:latin typeface="Neue Haas Grotesk Text Pro"/>
+                      </a:rPr>
+                      <a:t>16 (6%)</a:t>
+                    </a:r>
+                  </a:p>
+                </c:rich>
+              </c:tx>
+              <c:showLegendKey val="0"/>
+              <c:showVal val="1"/>
+              <c:showCatName val="0"/>
+              <c:showSerName val="0"/>
+              <c:showPercent val="0"/>
+              <c:showBubbleSize val="0"/>
+            </c:dLbl>
+            <c:dLbl>
+              <c:idx val="1"/>
+              <c:tx>
+                <c:rich>
+                  <a:bodyPr/>
+                  <a:lstStyle/>
+                  <a:p>
+                    <a:r>
+                      <a:rPr sz="1100" b="1">
+                        <a:solidFill>
+                          <a:srgbClr val="FFFFFF"/>
+                        </a:solidFill>
+                        <a:latin typeface="Neue Haas Grotesk Text Pro"/>
+                      </a:rPr>
+                      <a:t>17 (9%)</a:t>
+                    </a:r>
+                  </a:p>
+                </c:rich>
+              </c:tx>
+              <c:showLegendKey val="0"/>
+              <c:showVal val="1"/>
+              <c:showCatName val="0"/>
+              <c:showSerName val="0"/>
+              <c:showPercent val="0"/>
+              <c:showBubbleSize val="0"/>
+            </c:dLbl>
+            <c:dLbl>
+              <c:idx val="2"/>
+              <c:tx>
+                <c:rich>
+                  <a:bodyPr/>
+                  <a:lstStyle/>
+                  <a:p>
+                    <a:r>
+                      <a:rPr sz="1100" b="1">
+                        <a:solidFill>
+                          <a:srgbClr val="FFFFFF"/>
+                        </a:solidFill>
+                        <a:latin typeface="Neue Haas Grotesk Text Pro"/>
+                      </a:rPr>
+                      <a:t>39 (17%)</a:t>
+                    </a:r>
+                  </a:p>
+                </c:rich>
+              </c:tx>
+              <c:showLegendKey val="0"/>
+              <c:showVal val="1"/>
+              <c:showCatName val="0"/>
+              <c:showSerName val="0"/>
+              <c:showPercent val="0"/>
+              <c:showBubbleSize val="0"/>
+            </c:dLbl>
+            <c:dLbl>
+              <c:idx val="3"/>
+              <c:tx>
+                <c:rich>
+                  <a:bodyPr/>
+                  <a:lstStyle/>
+                  <a:p>
+                    <a:r>
+                      <a:rPr sz="1100" b="1">
+                        <a:solidFill>
+                          <a:srgbClr val="FFFFFF"/>
+                        </a:solidFill>
+                        <a:latin typeface="Neue Haas Grotesk Text Pro"/>
+                      </a:rPr>
+                      <a:t>3 (4%)</a:t>
+                    </a:r>
+                  </a:p>
+                </c:rich>
+              </c:tx>
+              <c:showLegendKey val="0"/>
+              <c:showVal val="1"/>
+              <c:showCatName val="0"/>
+              <c:showSerName val="0"/>
+              <c:showPercent val="0"/>
+              <c:showBubbleSize val="0"/>
+            </c:dLbl>
+            <c:dLbl>
+              <c:idx val="4"/>
+              <c:tx>
+                <c:rich>
+                  <a:bodyPr/>
+                  <a:lstStyle/>
+                  <a:p>
+                    <a:r>
+                      <a:rPr sz="1100" b="1">
+                        <a:solidFill>
+                          <a:srgbClr val="FFFFFF"/>
+                        </a:solidFill>
+                        <a:latin typeface="Neue Haas Grotesk Text Pro"/>
+                      </a:rPr>
+                      <a:t>75 (10%)</a:t>
+                    </a:r>
+                  </a:p>
+                </c:rich>
+              </c:tx>
+              <c:showLegendKey val="0"/>
+              <c:showVal val="1"/>
+              <c:showCatName val="0"/>
+              <c:showSerName val="0"/>
+              <c:showPercent val="0"/>
+              <c:showBubbleSize val="0"/>
+            </c:dLbl>
+            <c:showLegendKey val="0"/>
+            <c:showVal val="0"/>
+            <c:showCatName val="0"/>
+            <c:showSerName val="0"/>
+            <c:showPercent val="0"/>
+            <c:showBubbleSize val="0"/>
+            <c:showLeaderLines val="1"/>
+          </c:dLbls>
+          <c:cat>
+            <c:strRef>
+              <c:f>Sheet1!$A$2:$A$6</c:f>
+              <c:strCache>
+                <c:ptCount val="5"/>
+                <c:pt idx="0">
+                  <c:v>2023</c:v>
+                </c:pt>
+                <c:pt idx="1">
+                  <c:v>2024</c:v>
+                </c:pt>
+                <c:pt idx="2">
+                  <c:v>2025</c:v>
+                </c:pt>
                 <c:pt idx="3">
+                  <c:v>2026*</c:v>
+                </c:pt>
+                <c:pt idx="4">
+                  <c:v>Total</c:v>
+                </c:pt>
+              </c:strCache>
+            </c:strRef>
+          </c:cat>
+          <c:val>
+            <c:numRef>
+              <c:f>Sheet1!$E$2:$E$6</c:f>
+              <c:numCache>
+                <c:formatCode>General</c:formatCode>
+                <c:ptCount val="5"/>
+                <c:pt idx="0">
+                  <c:v>16</c:v>
+                </c:pt>
+                <c:pt idx="1">
+                  <c:v>17</c:v>
+                </c:pt>
+                <c:pt idx="2">
+                  <c:v>39</c:v>
+                </c:pt>
+                <c:pt idx="3">
+                  <c:v>3</c:v>
+                </c:pt>
+                <c:pt idx="4">
                   <c:v>75</c:v>
                 </c:pt>
               </c:numCache>
             </c:numRef>
           </c:val>
         </c:ser>
-        <c:gapWidth val="45"/>
+        <c:gapWidth val="50"/>
+        <c:overlap val="100"/>
         <c:axId val="-2068027336"/>
         <c:axId val="-2113994440"/>
       </c:barChart>
@@ -373,7 +981,7 @@
           <a:lstStyle/>
           <a:p>
             <a:pPr>
-              <a:defRPr sz="1400" b="1">
+              <a:defRPr sz="1300" b="1">
                 <a:latin typeface="Neue Haas Grotesk Text Pro"/>
               </a:defRPr>
             </a:pPr>
@@ -398,6 +1006,21 @@
         <c:crosses val="autoZero"/>
       </c:valAx>
     </c:plotArea>
+    <c:legend>
+      <c:legendPos val="b"/>
+      <c:overlay val="0"/>
+      <c:txPr>
+        <a:bodyPr/>
+        <a:lstStyle/>
+        <a:p>
+          <a:pPr>
+            <a:defRPr sz="1100">
+              <a:latin typeface="Neue Haas Grotesk Text Pro"/>
+            </a:defRPr>
+          </a:pPr>
+        </a:p>
+      </c:txPr>
+    </c:legend>
     <c:dispBlanksAs val="gap"/>
   </c:chart>
   <c:txPr>
@@ -420,11 +1043,11 @@
 <c:chartSpace xmlns:c="http://schemas.openxmlformats.org/drawingml/2006/chart" xmlns:a="http://schemas.openxmlformats.org/drawingml/2006/main" xmlns:r="http://schemas.openxmlformats.org/officeDocument/2006/relationships">
   <c:date1904 val="0"/>
   <c:chart>
-    <c:autoTitleDeleted val="1"/>
+    <c:autoTitleDeleted val="0"/>
     <c:plotArea>
       <c:barChart>
         <c:barDir val="col"/>
-        <c:grouping val="clustered"/>
+        <c:grouping val="percentStacked"/>
         <c:ser>
           <c:idx val="0"/>
           <c:order val="0"/>
@@ -434,43 +1057,21 @@
               <c:strCache>
                 <c:ptCount val="1"/>
                 <c:pt idx="0">
-                  <c:v>USD</c:v>
+                  <c:v>Light</c:v>
                 </c:pt>
               </c:strCache>
             </c:strRef>
           </c:tx>
-          <c:dPt>
-            <c:idx val="0"/>
-            <c:spPr>
+          <c:spPr>
+            <a:solidFill>
+              <a:srgbClr val="D9D9D9"/>
+            </a:solidFill>
+            <a:ln>
               <a:solidFill>
-                <a:srgbClr val="D9D9D9"/>
+                <a:srgbClr val="FFFFFF"/>
               </a:solidFill>
-            </c:spPr>
-          </c:dPt>
-          <c:dPt>
-            <c:idx val="1"/>
-            <c:spPr>
-              <a:solidFill>
-                <a:srgbClr val="A6A6A6"/>
-              </a:solidFill>
-            </c:spPr>
-          </c:dPt>
-          <c:dPt>
-            <c:idx val="2"/>
-            <c:spPr>
-              <a:solidFill>
-                <a:srgbClr val="595959"/>
-              </a:solidFill>
-            </c:spPr>
-          </c:dPt>
-          <c:dPt>
-            <c:idx val="3"/>
-            <c:spPr>
-              <a:solidFill>
-                <a:srgbClr val="000000"/>
-              </a:solidFill>
-            </c:spPr>
-          </c:dPt>
+            </a:ln>
+          </c:spPr>
           <c:dLbls>
             <c:dLbl>
               <c:idx val="0"/>
@@ -480,26 +1081,17 @@
                   <a:lstStyle/>
                   <a:p>
                     <a:r>
-                      <a:rPr sz="1500" b="1">
-                        <a:latin typeface="Neue Haas Grotesk Text Pro"/>
-                      </a:rPr>
-                      <a:t>$3,02 M</a:t>
-                    </a:r>
-                  </a:p>
-                  <a:p>
-                    <a:r>
-                      <a:rPr sz="1200">
+                      <a:rPr sz="1400" b="1">
                         <a:solidFill>
-                          <a:srgbClr val="6B6B6B"/>
+                          <a:srgbClr val="000000"/>
                         </a:solidFill>
                         <a:latin typeface="Neue Haas Grotesk Text Pro"/>
                       </a:rPr>
-                      <a:t>14% share</a:t>
+                      <a:t>32%</a:t>
                     </a:r>
                   </a:p>
                 </c:rich>
               </c:tx>
-              <c:dLblPos val="outEnd"/>
               <c:showLegendKey val="0"/>
               <c:showVal val="1"/>
               <c:showCatName val="0"/>
@@ -515,96 +1107,17 @@
                   <a:lstStyle/>
                   <a:p>
                     <a:r>
-                      <a:rPr sz="1500" b="1">
-                        <a:latin typeface="Neue Haas Grotesk Text Pro"/>
-                      </a:rPr>
-                      <a:t>$5,04 M</a:t>
-                    </a:r>
-                  </a:p>
-                  <a:p>
-                    <a:r>
-                      <a:rPr sz="1200">
+                      <a:rPr sz="1400" b="1">
                         <a:solidFill>
-                          <a:srgbClr val="6B6B6B"/>
+                          <a:srgbClr val="000000"/>
                         </a:solidFill>
                         <a:latin typeface="Neue Haas Grotesk Text Pro"/>
                       </a:rPr>
-                      <a:t>24% share</a:t>
+                      <a:t>14%</a:t>
                     </a:r>
                   </a:p>
                 </c:rich>
               </c:tx>
-              <c:dLblPos val="outEnd"/>
-              <c:showLegendKey val="0"/>
-              <c:showVal val="1"/>
-              <c:showCatName val="0"/>
-              <c:showSerName val="0"/>
-              <c:showPercent val="0"/>
-              <c:showBubbleSize val="0"/>
-            </c:dLbl>
-            <c:dLbl>
-              <c:idx val="2"/>
-              <c:tx>
-                <c:rich>
-                  <a:bodyPr/>
-                  <a:lstStyle/>
-                  <a:p>
-                    <a:r>
-                      <a:rPr sz="1500" b="1">
-                        <a:latin typeface="Neue Haas Grotesk Text Pro"/>
-                      </a:rPr>
-                      <a:t>$7,30 M</a:t>
-                    </a:r>
-                  </a:p>
-                  <a:p>
-                    <a:r>
-                      <a:rPr sz="1200">
-                        <a:solidFill>
-                          <a:srgbClr val="6B6B6B"/>
-                        </a:solidFill>
-                        <a:latin typeface="Neue Haas Grotesk Text Pro"/>
-                      </a:rPr>
-                      <a:t>35% share</a:t>
-                    </a:r>
-                  </a:p>
-                </c:rich>
-              </c:tx>
-              <c:dLblPos val="outEnd"/>
-              <c:showLegendKey val="0"/>
-              <c:showVal val="1"/>
-              <c:showCatName val="0"/>
-              <c:showSerName val="0"/>
-              <c:showPercent val="0"/>
-              <c:showBubbleSize val="0"/>
-            </c:dLbl>
-            <c:dLbl>
-              <c:idx val="3"/>
-              <c:tx>
-                <c:rich>
-                  <a:bodyPr/>
-                  <a:lstStyle/>
-                  <a:p>
-                    <a:r>
-                      <a:rPr sz="1500" b="1">
-                        <a:latin typeface="Neue Haas Grotesk Text Pro"/>
-                      </a:rPr>
-                      <a:t>$5,71 M</a:t>
-                    </a:r>
-                  </a:p>
-                  <a:p>
-                    <a:r>
-                      <a:rPr sz="1200">
-                        <a:solidFill>
-                          <a:srgbClr val="6B6B6B"/>
-                        </a:solidFill>
-                        <a:latin typeface="Neue Haas Grotesk Text Pro"/>
-                      </a:rPr>
-                      <a:t>27% share</a:t>
-                    </a:r>
-                  </a:p>
-                </c:rich>
-              </c:tx>
-              <c:dLblPos val="outEnd"/>
               <c:showLegendKey val="0"/>
               <c:showVal val="1"/>
               <c:showCatName val="0"/>
@@ -622,47 +1135,381 @@
           </c:dLbls>
           <c:cat>
             <c:strRef>
-              <c:f>Sheet1!$A$2:$A$5</c:f>
+              <c:f>Sheet1!$A$2:$A$3</c:f>
               <c:strCache>
-                <c:ptCount val="4"/>
+                <c:ptCount val="2"/>
                 <c:pt idx="0">
-                  <c:v>Light</c:v>
+                  <c:v>Units</c:v>
                 </c:pt>
                 <c:pt idx="1">
-                  <c:v>Small</c:v>
-                </c:pt>
-                <c:pt idx="2">
-                  <c:v>Medium</c:v>
-                </c:pt>
-                <c:pt idx="3">
-                  <c:v>Heavy</c:v>
+                  <c:v>Value</c:v>
                 </c:pt>
               </c:strCache>
             </c:strRef>
           </c:cat>
           <c:val>
             <c:numRef>
-              <c:f>Sheet1!$B$2:$B$5</c:f>
+              <c:f>Sheet1!$B$2:$B$3</c:f>
               <c:numCache>
                 <c:formatCode>General</c:formatCode>
-                <c:ptCount val="4"/>
+                <c:ptCount val="2"/>
                 <c:pt idx="0">
+                  <c:v>248</c:v>
+                </c:pt>
+                <c:pt idx="1">
                   <c:v>3019088</c:v>
+                </c:pt>
+              </c:numCache>
+            </c:numRef>
+          </c:val>
+        </c:ser>
+        <c:ser>
+          <c:idx val="1"/>
+          <c:order val="1"/>
+          <c:tx>
+            <c:strRef>
+              <c:f>Sheet1!$C$1</c:f>
+              <c:strCache>
+                <c:ptCount val="1"/>
+                <c:pt idx="0">
+                  <c:v>Small</c:v>
+                </c:pt>
+              </c:strCache>
+            </c:strRef>
+          </c:tx>
+          <c:spPr>
+            <a:solidFill>
+              <a:srgbClr val="A6A6A6"/>
+            </a:solidFill>
+            <a:ln>
+              <a:solidFill>
+                <a:srgbClr val="FFFFFF"/>
+              </a:solidFill>
+            </a:ln>
+          </c:spPr>
+          <c:dLbls>
+            <c:dLbl>
+              <c:idx val="0"/>
+              <c:tx>
+                <c:rich>
+                  <a:bodyPr/>
+                  <a:lstStyle/>
+                  <a:p>
+                    <a:r>
+                      <a:rPr sz="1400" b="1">
+                        <a:solidFill>
+                          <a:srgbClr val="000000"/>
+                        </a:solidFill>
+                        <a:latin typeface="Neue Haas Grotesk Text Pro"/>
+                      </a:rPr>
+                      <a:t>29%</a:t>
+                    </a:r>
+                  </a:p>
+                </c:rich>
+              </c:tx>
+              <c:showLegendKey val="0"/>
+              <c:showVal val="1"/>
+              <c:showCatName val="0"/>
+              <c:showSerName val="0"/>
+              <c:showPercent val="0"/>
+              <c:showBubbleSize val="0"/>
+            </c:dLbl>
+            <c:dLbl>
+              <c:idx val="1"/>
+              <c:tx>
+                <c:rich>
+                  <a:bodyPr/>
+                  <a:lstStyle/>
+                  <a:p>
+                    <a:r>
+                      <a:rPr sz="1400" b="1">
+                        <a:solidFill>
+                          <a:srgbClr val="000000"/>
+                        </a:solidFill>
+                        <a:latin typeface="Neue Haas Grotesk Text Pro"/>
+                      </a:rPr>
+                      <a:t>24%</a:t>
+                    </a:r>
+                  </a:p>
+                </c:rich>
+              </c:tx>
+              <c:showLegendKey val="0"/>
+              <c:showVal val="1"/>
+              <c:showCatName val="0"/>
+              <c:showSerName val="0"/>
+              <c:showPercent val="0"/>
+              <c:showBubbleSize val="0"/>
+            </c:dLbl>
+            <c:showLegendKey val="0"/>
+            <c:showVal val="0"/>
+            <c:showCatName val="0"/>
+            <c:showSerName val="0"/>
+            <c:showPercent val="0"/>
+            <c:showBubbleSize val="0"/>
+            <c:showLeaderLines val="1"/>
+          </c:dLbls>
+          <c:cat>
+            <c:strRef>
+              <c:f>Sheet1!$A$2:$A$3</c:f>
+              <c:strCache>
+                <c:ptCount val="2"/>
+                <c:pt idx="0">
+                  <c:v>Units</c:v>
+                </c:pt>
+                <c:pt idx="1">
+                  <c:v>Value</c:v>
+                </c:pt>
+              </c:strCache>
+            </c:strRef>
+          </c:cat>
+          <c:val>
+            <c:numRef>
+              <c:f>Sheet1!$C$2:$C$3</c:f>
+              <c:numCache>
+                <c:formatCode>General</c:formatCode>
+                <c:ptCount val="2"/>
+                <c:pt idx="0">
+                  <c:v>223</c:v>
                 </c:pt>
                 <c:pt idx="1">
                   <c:v>5037297</c:v>
                 </c:pt>
-                <c:pt idx="2">
+              </c:numCache>
+            </c:numRef>
+          </c:val>
+        </c:ser>
+        <c:ser>
+          <c:idx val="2"/>
+          <c:order val="2"/>
+          <c:tx>
+            <c:strRef>
+              <c:f>Sheet1!$D$1</c:f>
+              <c:strCache>
+                <c:ptCount val="1"/>
+                <c:pt idx="0">
+                  <c:v>Medium</c:v>
+                </c:pt>
+              </c:strCache>
+            </c:strRef>
+          </c:tx>
+          <c:spPr>
+            <a:solidFill>
+              <a:srgbClr val="595959"/>
+            </a:solidFill>
+            <a:ln>
+              <a:solidFill>
+                <a:srgbClr val="FFFFFF"/>
+              </a:solidFill>
+            </a:ln>
+          </c:spPr>
+          <c:dLbls>
+            <c:dLbl>
+              <c:idx val="0"/>
+              <c:tx>
+                <c:rich>
+                  <a:bodyPr/>
+                  <a:lstStyle/>
+                  <a:p>
+                    <a:r>
+                      <a:rPr sz="1400" b="1">
+                        <a:solidFill>
+                          <a:srgbClr val="FFFFFF"/>
+                        </a:solidFill>
+                        <a:latin typeface="Neue Haas Grotesk Text Pro"/>
+                      </a:rPr>
+                      <a:t>29%</a:t>
+                    </a:r>
+                  </a:p>
+                </c:rich>
+              </c:tx>
+              <c:showLegendKey val="0"/>
+              <c:showVal val="1"/>
+              <c:showCatName val="0"/>
+              <c:showSerName val="0"/>
+              <c:showPercent val="0"/>
+              <c:showBubbleSize val="0"/>
+            </c:dLbl>
+            <c:dLbl>
+              <c:idx val="1"/>
+              <c:tx>
+                <c:rich>
+                  <a:bodyPr/>
+                  <a:lstStyle/>
+                  <a:p>
+                    <a:r>
+                      <a:rPr sz="1400" b="1">
+                        <a:solidFill>
+                          <a:srgbClr val="FFFFFF"/>
+                        </a:solidFill>
+                        <a:latin typeface="Neue Haas Grotesk Text Pro"/>
+                      </a:rPr>
+                      <a:t>35%</a:t>
+                    </a:r>
+                  </a:p>
+                </c:rich>
+              </c:tx>
+              <c:showLegendKey val="0"/>
+              <c:showVal val="1"/>
+              <c:showCatName val="0"/>
+              <c:showSerName val="0"/>
+              <c:showPercent val="0"/>
+              <c:showBubbleSize val="0"/>
+            </c:dLbl>
+            <c:showLegendKey val="0"/>
+            <c:showVal val="0"/>
+            <c:showCatName val="0"/>
+            <c:showSerName val="0"/>
+            <c:showPercent val="0"/>
+            <c:showBubbleSize val="0"/>
+            <c:showLeaderLines val="1"/>
+          </c:dLbls>
+          <c:cat>
+            <c:strRef>
+              <c:f>Sheet1!$A$2:$A$3</c:f>
+              <c:strCache>
+                <c:ptCount val="2"/>
+                <c:pt idx="0">
+                  <c:v>Units</c:v>
+                </c:pt>
+                <c:pt idx="1">
+                  <c:v>Value</c:v>
+                </c:pt>
+              </c:strCache>
+            </c:strRef>
+          </c:cat>
+          <c:val>
+            <c:numRef>
+              <c:f>Sheet1!$D$2:$D$3</c:f>
+              <c:numCache>
+                <c:formatCode>General</c:formatCode>
+                <c:ptCount val="2"/>
+                <c:pt idx="0">
+                  <c:v>218</c:v>
+                </c:pt>
+                <c:pt idx="1">
                   <c:v>7304431</c:v>
                 </c:pt>
-                <c:pt idx="3">
+              </c:numCache>
+            </c:numRef>
+          </c:val>
+        </c:ser>
+        <c:ser>
+          <c:idx val="3"/>
+          <c:order val="3"/>
+          <c:tx>
+            <c:strRef>
+              <c:f>Sheet1!$E$1</c:f>
+              <c:strCache>
+                <c:ptCount val="1"/>
+                <c:pt idx="0">
+                  <c:v>Heavy</c:v>
+                </c:pt>
+              </c:strCache>
+            </c:strRef>
+          </c:tx>
+          <c:spPr>
+            <a:solidFill>
+              <a:srgbClr val="000000"/>
+            </a:solidFill>
+            <a:ln>
+              <a:solidFill>
+                <a:srgbClr val="FFFFFF"/>
+              </a:solidFill>
+            </a:ln>
+          </c:spPr>
+          <c:dLbls>
+            <c:dLbl>
+              <c:idx val="0"/>
+              <c:tx>
+                <c:rich>
+                  <a:bodyPr/>
+                  <a:lstStyle/>
+                  <a:p>
+                    <a:r>
+                      <a:rPr sz="1400" b="1">
+                        <a:solidFill>
+                          <a:srgbClr val="FFFFFF"/>
+                        </a:solidFill>
+                        <a:latin typeface="Neue Haas Grotesk Text Pro"/>
+                      </a:rPr>
+                      <a:t>10%</a:t>
+                    </a:r>
+                  </a:p>
+                </c:rich>
+              </c:tx>
+              <c:showLegendKey val="0"/>
+              <c:showVal val="1"/>
+              <c:showCatName val="0"/>
+              <c:showSerName val="0"/>
+              <c:showPercent val="0"/>
+              <c:showBubbleSize val="0"/>
+            </c:dLbl>
+            <c:dLbl>
+              <c:idx val="1"/>
+              <c:tx>
+                <c:rich>
+                  <a:bodyPr/>
+                  <a:lstStyle/>
+                  <a:p>
+                    <a:r>
+                      <a:rPr sz="1400" b="1">
+                        <a:solidFill>
+                          <a:srgbClr val="FFFFFF"/>
+                        </a:solidFill>
+                        <a:latin typeface="Neue Haas Grotesk Text Pro"/>
+                      </a:rPr>
+                      <a:t>27%</a:t>
+                    </a:r>
+                  </a:p>
+                </c:rich>
+              </c:tx>
+              <c:showLegendKey val="0"/>
+              <c:showVal val="1"/>
+              <c:showCatName val="0"/>
+              <c:showSerName val="0"/>
+              <c:showPercent val="0"/>
+              <c:showBubbleSize val="0"/>
+            </c:dLbl>
+            <c:showLegendKey val="0"/>
+            <c:showVal val="0"/>
+            <c:showCatName val="0"/>
+            <c:showSerName val="0"/>
+            <c:showPercent val="0"/>
+            <c:showBubbleSize val="0"/>
+            <c:showLeaderLines val="1"/>
+          </c:dLbls>
+          <c:cat>
+            <c:strRef>
+              <c:f>Sheet1!$A$2:$A$3</c:f>
+              <c:strCache>
+                <c:ptCount val="2"/>
+                <c:pt idx="0">
+                  <c:v>Units</c:v>
+                </c:pt>
+                <c:pt idx="1">
+                  <c:v>Value</c:v>
+                </c:pt>
+              </c:strCache>
+            </c:strRef>
+          </c:cat>
+          <c:val>
+            <c:numRef>
+              <c:f>Sheet1!$E$2:$E$3</c:f>
+              <c:numCache>
+                <c:formatCode>General</c:formatCode>
+                <c:ptCount val="2"/>
+                <c:pt idx="0">
+                  <c:v>75</c:v>
+                </c:pt>
+                <c:pt idx="1">
                   <c:v>5712582</c:v>
                 </c:pt>
               </c:numCache>
             </c:numRef>
           </c:val>
         </c:ser>
-        <c:gapWidth val="45"/>
+        <c:gapWidth val="90"/>
+        <c:overlap val="100"/>
         <c:axId val="-2068027336"/>
         <c:axId val="-2113994440"/>
       </c:barChart>
@@ -681,7 +1528,7 @@
           <a:lstStyle/>
           <a:p>
             <a:pPr>
-              <a:defRPr sz="1400" b="1">
+              <a:defRPr sz="1300" b="1">
                 <a:latin typeface="Neue Haas Grotesk Text Pro"/>
               </a:defRPr>
             </a:pPr>
@@ -706,6 +1553,21 @@
         <c:crosses val="autoZero"/>
       </c:valAx>
     </c:plotArea>
+    <c:legend>
+      <c:legendPos val="b"/>
+      <c:overlay val="0"/>
+      <c:txPr>
+        <a:bodyPr/>
+        <a:lstStyle/>
+        <a:p>
+          <a:pPr>
+            <a:defRPr sz="1100">
+              <a:latin typeface="Neue Haas Grotesk Text Pro"/>
+            </a:defRPr>
+          </a:pPr>
+        </a:p>
+      </c:txPr>
+    </c:legend>
     <c:dispBlanksAs val="gap"/>
   </c:chart>
   <c:txPr>
@@ -3784,8 +4646,8 @@
           <p:nvPr/>
         </p:nvGraphicFramePr>
         <p:xfrm>
-          <a:off x="342900" y="1333500"/>
-          <a:ext cx="5334000" cy="4476750"/>
+          <a:off x="342900" y="1238250"/>
+          <a:ext cx="5334000" cy="5048250"/>
         </p:xfrm>
         <a:graphic>
           <a:graphicData uri="http://schemas.openxmlformats.org/drawingml/2006/chart">
@@ -5025,7 +5887,7 @@
                 </a:solidFill>
                 <a:latin typeface="Neue Haas Grotesk Text Pro"/>
               </a:rPr>
-              <a:t>But Medium and Heavy bring most of the value</a:t>
+              <a:t>Heavy is 10% of units but 27% of value</a:t>
             </a:r>
           </a:p>
         </p:txBody>
@@ -5074,8 +5936,8 @@
           <p:nvPr/>
         </p:nvGraphicFramePr>
         <p:xfrm>
-          <a:off x="342900" y="1333500"/>
-          <a:ext cx="5334000" cy="4476750"/>
+          <a:off x="342900" y="1238250"/>
+          <a:ext cx="5334000" cy="5048250"/>
         </p:xfrm>
         <a:graphic>
           <a:graphicData uri="http://schemas.openxmlformats.org/drawingml/2006/chart">

</xml_diff>

<commit_message>
Use dark-to-light green for tm classes in QTY vs Value slides
Co-Authored-By: Claude Opus 5.5 <noreply@anthropic.com>
Claude-Session: https://claude.ai/code/session_01Cx9kswyecF7JAB1Rr5vVcV
</commit_message>
<xml_diff>
--- a/nedp_deck/QTY_vs_Value_2slides.pptx
+++ b/nedp_deck/QTY_vs_Value_2slides.pptx
@@ -133,7 +133,7 @@
           </c:tx>
           <c:spPr>
             <a:solidFill>
-              <a:srgbClr val="D9D9D9"/>
+              <a:srgbClr val="C7EFD5"/>
             </a:solidFill>
             <a:ln>
               <a:solidFill>
@@ -344,7 +344,7 @@
           </c:tx>
           <c:spPr>
             <a:solidFill>
-              <a:srgbClr val="A6A6A6"/>
+              <a:srgbClr val="6FCF97"/>
             </a:solidFill>
             <a:ln>
               <a:solidFill>
@@ -555,7 +555,7 @@
           </c:tx>
           <c:spPr>
             <a:solidFill>
-              <a:srgbClr val="595959"/>
+              <a:srgbClr val="1E9E57"/>
             </a:solidFill>
             <a:ln>
               <a:solidFill>
@@ -766,7 +766,7 @@
           </c:tx>
           <c:spPr>
             <a:solidFill>
-              <a:srgbClr val="000000"/>
+              <a:srgbClr val="0B4D2A"/>
             </a:solidFill>
             <a:ln>
               <a:solidFill>
@@ -1064,7 +1064,7 @@
           </c:tx>
           <c:spPr>
             <a:solidFill>
-              <a:srgbClr val="D9D9D9"/>
+              <a:srgbClr val="C7EFD5"/>
             </a:solidFill>
             <a:ln>
               <a:solidFill>
@@ -1179,7 +1179,7 @@
           </c:tx>
           <c:spPr>
             <a:solidFill>
-              <a:srgbClr val="A6A6A6"/>
+              <a:srgbClr val="6FCF97"/>
             </a:solidFill>
             <a:ln>
               <a:solidFill>
@@ -1294,7 +1294,7 @@
           </c:tx>
           <c:spPr>
             <a:solidFill>
-              <a:srgbClr val="595959"/>
+              <a:srgbClr val="1E9E57"/>
             </a:solidFill>
             <a:ln>
               <a:solidFill>
@@ -1409,7 +1409,7 @@
           </c:tx>
           <c:spPr>
             <a:solidFill>
-              <a:srgbClr val="000000"/>
+              <a:srgbClr val="0B4D2A"/>
             </a:solidFill>
             <a:ln>
               <a:solidFill>

</xml_diff>